<commit_message>
chore(docs): align schedule, totals and presentation
</commit_message>
<xml_diff>
--- a/docs/presentacion_entrega_2.pptx
+++ b/docs/presentacion_entrega_2.pptx
@@ -9262,7 +9262,7 @@
                   <a:srgbClr val="BFD7ED"/>
                 </a:solidFill>
               </a:rPr>
-              <a:t>Fecha base: 10-03-2026 · Metodología Cascada · 8 fases · 4 hitos · 552 horas totales</a:t>
+              <a:t>Fecha base: 10-03-2026 · Metodología Cascada · 8 fases · 4 hitos · 576 horas totales</a:t>
             </a:r>
           </a:p>
         </p:txBody>
@@ -10125,7 +10125,7 @@
                   <a:srgbClr val="FFFFFF"/>
                 </a:solidFill>
               </a:rPr>
-              <a:t>17-03</a:t>
+              <a:t>22-03</a:t>
             </a:r>
           </a:p>
         </p:txBody>
@@ -10496,7 +10496,7 @@
                   <a:srgbClr val="404040"/>
                 </a:solidFill>
               </a:rPr>
-              <a:t>11-03</a:t>
+              <a:t>13-03</a:t>
             </a:r>
           </a:p>
         </p:txBody>
@@ -10814,7 +10814,7 @@
                   <a:srgbClr val="404040"/>
                 </a:solidFill>
               </a:rPr>
-              <a:t>14-03</a:t>
+              <a:t>18-03</a:t>
             </a:r>
           </a:p>
         </p:txBody>
@@ -10867,7 +10867,7 @@
                   <a:srgbClr val="404040"/>
                 </a:solidFill>
               </a:rPr>
-              <a:t>15-03</a:t>
+              <a:t>22-03</a:t>
             </a:r>
           </a:p>
         </p:txBody>
@@ -11026,7 +11026,7 @@
                   <a:srgbClr val="7F5000"/>
                 </a:solidFill>
               </a:rPr>
-              <a:t>⬛ Análisis Reqs. Completado</a:t>
+              <a:t>Análisis Reqs. Completado</a:t>
             </a:r>
           </a:p>
         </p:txBody>
@@ -11185,7 +11185,7 @@
                   <a:srgbClr val="7F5000"/>
                 </a:solidFill>
               </a:rPr>
-              <a:t>22-03</a:t>
+              <a:t>06-04</a:t>
             </a:r>
           </a:p>
         </p:txBody>
@@ -11238,7 +11238,7 @@
                   <a:srgbClr val="7F5000"/>
                 </a:solidFill>
               </a:rPr>
-              <a:t>22-03</a:t>
+              <a:t>06-04</a:t>
             </a:r>
           </a:p>
         </p:txBody>
@@ -11556,7 +11556,7 @@
                   <a:srgbClr val="FFFFFF"/>
                 </a:solidFill>
               </a:rPr>
-              <a:t>30-03</a:t>
+              <a:t>10-04</a:t>
             </a:r>
           </a:p>
         </p:txBody>
@@ -11609,7 +11609,7 @@
                   <a:srgbClr val="FFFFFF"/>
                 </a:solidFill>
               </a:rPr>
-              <a:t>11-04</a:t>
+              <a:t>04-05</a:t>
             </a:r>
           </a:p>
         </p:txBody>
@@ -11927,7 +11927,7 @@
                   <a:srgbClr val="404040"/>
                 </a:solidFill>
               </a:rPr>
-              <a:t>07-04</a:t>
+              <a:t>28-04</a:t>
             </a:r>
           </a:p>
         </p:txBody>
@@ -11980,7 +11980,7 @@
                   <a:srgbClr val="404040"/>
                 </a:solidFill>
               </a:rPr>
-              <a:t>13-04</a:t>
+              <a:t>01-05</a:t>
             </a:r>
           </a:p>
         </p:txBody>
@@ -12298,7 +12298,7 @@
                   <a:srgbClr val="404040"/>
                 </a:solidFill>
               </a:rPr>
-              <a:t>13-04</a:t>
+              <a:t>02-05</a:t>
             </a:r>
           </a:p>
         </p:txBody>
@@ -12351,7 +12351,7 @@
                   <a:srgbClr val="404040"/>
                 </a:solidFill>
               </a:rPr>
-              <a:t>15-04</a:t>
+              <a:t>03-05</a:t>
             </a:r>
           </a:p>
         </p:txBody>
@@ -12510,7 +12510,7 @@
                   <a:srgbClr val="7F5000"/>
                 </a:solidFill>
               </a:rPr>
-              <a:t>⬛ Diseño Completado</a:t>
+              <a:t>Diseño Completado</a:t>
             </a:r>
           </a:p>
         </p:txBody>
@@ -12669,7 +12669,7 @@
                   <a:srgbClr val="7F5000"/>
                 </a:solidFill>
               </a:rPr>
-              <a:t>29-03</a:t>
+              <a:t>09-04</a:t>
             </a:r>
           </a:p>
         </p:txBody>
@@ -12722,7 +12722,7 @@
                   <a:srgbClr val="7F5000"/>
                 </a:solidFill>
               </a:rPr>
-              <a:t>29-03</a:t>
+              <a:t>09-04</a:t>
             </a:r>
           </a:p>
         </p:txBody>
@@ -12881,7 +12881,7 @@
                   <a:srgbClr val="7F5000"/>
                 </a:solidFill>
               </a:rPr>
-              <a:t>⬛ Sistema Aprobado Despliegue</a:t>
+              <a:t>Sistema Aprobado Despliegue</a:t>
             </a:r>
           </a:p>
         </p:txBody>
@@ -13040,7 +13040,7 @@
                   <a:srgbClr val="7F5000"/>
                 </a:solidFill>
               </a:rPr>
-              <a:t>27-04</a:t>
+              <a:t>01-06</a:t>
             </a:r>
           </a:p>
         </p:txBody>
@@ -13093,7 +13093,7 @@
                   <a:srgbClr val="7F5000"/>
                 </a:solidFill>
               </a:rPr>
-              <a:t>27-04</a:t>
+              <a:t>01-06</a:t>
             </a:r>
           </a:p>
         </p:txBody>
@@ -13252,7 +13252,7 @@
                   <a:srgbClr val="7F5000"/>
                 </a:solidFill>
               </a:rPr>
-              <a:t>⬛ Cierre Formal del Proyecto</a:t>
+              <a:t>Cierre Formal del Proyecto</a:t>
             </a:r>
           </a:p>
         </p:txBody>
@@ -13411,7 +13411,7 @@
                   <a:srgbClr val="7F5000"/>
                 </a:solidFill>
               </a:rPr>
-              <a:t>27-05</a:t>
+              <a:t>24-06</a:t>
             </a:r>
           </a:p>
         </p:txBody>
@@ -13464,7 +13464,7 @@
                   <a:srgbClr val="7F5000"/>
                 </a:solidFill>
               </a:rPr>
-              <a:t>27-05</a:t>
+              <a:t>24-06</a:t>
             </a:r>
           </a:p>
         </p:txBody>
@@ -13530,8 +13530,8 @@
         </p:nvSpPr>
         <p:spPr>
           <a:xfrm>
-            <a:off x="274320" y="5632704"/>
-            <a:ext cx="256032" cy="201168"/>
+            <a:off x="274320" y="5650992"/>
+            <a:ext cx="228600" cy="182880"/>
           </a:xfrm>
           <a:prstGeom prst="rect">
             <a:avLst/>
@@ -13575,8 +13575,8 @@
         </p:nvSpPr>
         <p:spPr>
           <a:xfrm>
-            <a:off x="594360" y="5632704"/>
-            <a:ext cx="1097280" cy="201168"/>
+            <a:off x="548640" y="5650992"/>
+            <a:ext cx="1280160" cy="182880"/>
           </a:xfrm>
           <a:prstGeom prst="rect">
             <a:avLst/>
@@ -13609,14 +13609,14 @@
         </p:nvSpPr>
         <p:spPr>
           <a:xfrm>
-            <a:off x="274320" y="5650992"/>
+            <a:off x="2103120" y="5650992"/>
             <a:ext cx="228600" cy="182880"/>
           </a:xfrm>
           <a:prstGeom prst="rect">
             <a:avLst/>
           </a:prstGeom>
           <a:solidFill>
-            <a:srgbClr val="2E75B6"/>
+            <a:srgbClr val="FFFFFF"/>
           </a:solidFill>
           <a:ln w="6350">
             <a:solidFill>
@@ -13654,7 +13654,7 @@
         </p:nvSpPr>
         <p:spPr>
           <a:xfrm>
-            <a:off x="548640" y="5650992"/>
+            <a:off x="2377439" y="5650992"/>
             <a:ext cx="1280160" cy="182880"/>
           </a:xfrm>
           <a:prstGeom prst="rect">
@@ -13675,7 +13675,7 @@
                   <a:srgbClr val="404040"/>
                 </a:solidFill>
               </a:rPr>
-              <a:t>Fase</a:t>
+              <a:t>Actividad</a:t>
             </a:r>
           </a:p>
         </p:txBody>
@@ -13688,14 +13688,14 @@
         </p:nvSpPr>
         <p:spPr>
           <a:xfrm>
-            <a:off x="2103120" y="5650992"/>
+            <a:off x="3931920" y="5650992"/>
             <a:ext cx="228600" cy="182880"/>
           </a:xfrm>
           <a:prstGeom prst="rect">
             <a:avLst/>
           </a:prstGeom>
           <a:solidFill>
-            <a:srgbClr val="FFFFFF"/>
+            <a:srgbClr val="FFF2CC"/>
           </a:solidFill>
           <a:ln w="6350">
             <a:solidFill>
@@ -13733,7 +13733,7 @@
         </p:nvSpPr>
         <p:spPr>
           <a:xfrm>
-            <a:off x="2377439" y="5650992"/>
+            <a:off x="4206240" y="5650992"/>
             <a:ext cx="1280160" cy="182880"/>
           </a:xfrm>
           <a:prstGeom prst="rect">
@@ -13754,7 +13754,7 @@
                   <a:srgbClr val="404040"/>
                 </a:solidFill>
               </a:rPr>
-              <a:t>Actividad</a:t>
+              <a:t>Hito (duración 0)</a:t>
             </a:r>
           </a:p>
         </p:txBody>
@@ -13767,19 +13767,17 @@
         </p:nvSpPr>
         <p:spPr>
           <a:xfrm>
-            <a:off x="3931920" y="5650992"/>
-            <a:ext cx="228600" cy="182880"/>
-          </a:xfrm>
-          <a:prstGeom prst="rect">
-            <a:avLst/>
-          </a:prstGeom>
-          <a:solidFill>
-            <a:srgbClr val="FFF2CC"/>
-          </a:solidFill>
-          <a:ln w="6350">
-            <a:solidFill>
-              <a:srgbClr val="808080"/>
-            </a:solidFill>
+            <a:off x="274320" y="5989320"/>
+            <a:ext cx="11612880" cy="475488"/>
+          </a:xfrm>
+          <a:prstGeom prst="rect">
+            <a:avLst/>
+          </a:prstGeom>
+          <a:solidFill>
+            <a:srgbClr val="1F3864"/>
+          </a:solidFill>
+          <a:ln>
+            <a:noFill/>
           </a:ln>
         </p:spPr>
         <p:style>
@@ -13812,8 +13810,8 @@
         </p:nvSpPr>
         <p:spPr>
           <a:xfrm>
-            <a:off x="4206240" y="5650992"/>
-            <a:ext cx="1280160" cy="182880"/>
+            <a:off x="457200" y="6007608"/>
+            <a:ext cx="2103120" cy="228600"/>
           </a:xfrm>
           <a:prstGeom prst="rect">
             <a:avLst/>
@@ -13828,69 +13826,26 @@
           <a:p>
             <a:pPr algn="l"/>
             <a:r>
-              <a:rPr sz="800" b="0" i="0">
-                <a:solidFill>
-                  <a:srgbClr val="404040"/>
-                </a:solidFill>
-              </a:rPr>
-              <a:t>Hito (duración 0)</a:t>
-            </a:r>
-          </a:p>
-        </p:txBody>
-      </p:sp>
-      <p:sp>
-        <p:nvSpPr>
-          <p:cNvPr id="97" name="Rectangle 96"/>
-          <p:cNvSpPr/>
-          <p:nvPr/>
-        </p:nvSpPr>
-        <p:spPr>
-          <a:xfrm>
-            <a:off x="274320" y="5989320"/>
-            <a:ext cx="11612880" cy="475488"/>
-          </a:xfrm>
-          <a:prstGeom prst="rect">
-            <a:avLst/>
-          </a:prstGeom>
-          <a:solidFill>
-            <a:srgbClr val="1F3864"/>
-          </a:solidFill>
-          <a:ln>
-            <a:noFill/>
-          </a:ln>
-        </p:spPr>
-        <p:style>
-          <a:lnRef idx="1">
-            <a:schemeClr val="accent1"/>
-          </a:lnRef>
-          <a:fillRef idx="3">
-            <a:schemeClr val="accent1"/>
-          </a:fillRef>
-          <a:effectRef idx="2">
-            <a:schemeClr val="accent1"/>
-          </a:effectRef>
-          <a:fontRef idx="minor">
-            <a:schemeClr val="lt1"/>
-          </a:fontRef>
-        </p:style>
-        <p:txBody>
-          <a:bodyPr rtlCol="0" anchor="ctr"/>
-          <a:lstStyle/>
-          <a:p>
-            <a:pPr algn="ctr"/>
-          </a:p>
-        </p:txBody>
-      </p:sp>
-      <p:sp>
-        <p:nvSpPr>
-          <p:cNvPr id="98" name="TextBox 97"/>
+              <a:rPr sz="1000" b="1" i="0">
+                <a:solidFill>
+                  <a:srgbClr val="FFC000"/>
+                </a:solidFill>
+              </a:rPr>
+              <a:t>8 Fases</a:t>
+            </a:r>
+          </a:p>
+        </p:txBody>
+      </p:sp>
+      <p:sp>
+        <p:nvSpPr>
+          <p:cNvPr id="97" name="TextBox 96"/>
           <p:cNvSpPr txBox="1"/>
           <p:nvPr/>
         </p:nvSpPr>
         <p:spPr>
           <a:xfrm>
-            <a:off x="457200" y="6007608"/>
-            <a:ext cx="2103120" cy="228600"/>
+            <a:off x="457200" y="6236208"/>
+            <a:ext cx="2103120" cy="182880"/>
           </a:xfrm>
           <a:prstGeom prst="rect">
             <a:avLst/>
@@ -13905,26 +13860,26 @@
           <a:p>
             <a:pPr algn="l"/>
             <a:r>
-              <a:rPr sz="1000" b="1" i="0">
-                <a:solidFill>
-                  <a:srgbClr val="FFC000"/>
-                </a:solidFill>
-              </a:rPr>
-              <a:t>8 Fases</a:t>
-            </a:r>
-          </a:p>
-        </p:txBody>
-      </p:sp>
-      <p:sp>
-        <p:nvSpPr>
-          <p:cNvPr id="99" name="TextBox 98"/>
+              <a:rPr sz="750" b="0" i="0">
+                <a:solidFill>
+                  <a:srgbClr val="BFD7ED"/>
+                </a:solidFill>
+              </a:rPr>
+              <a:t>Planificación → Cierre</a:t>
+            </a:r>
+          </a:p>
+        </p:txBody>
+      </p:sp>
+      <p:sp>
+        <p:nvSpPr>
+          <p:cNvPr id="98" name="TextBox 97"/>
           <p:cNvSpPr txBox="1"/>
           <p:nvPr/>
         </p:nvSpPr>
         <p:spPr>
           <a:xfrm>
-            <a:off x="457200" y="6236208"/>
-            <a:ext cx="2103120" cy="182880"/>
+            <a:off x="2788920" y="6007608"/>
+            <a:ext cx="2103120" cy="228600"/>
           </a:xfrm>
           <a:prstGeom prst="rect">
             <a:avLst/>
@@ -13939,26 +13894,26 @@
           <a:p>
             <a:pPr algn="l"/>
             <a:r>
-              <a:rPr sz="750" b="0" i="0">
-                <a:solidFill>
-                  <a:srgbClr val="BFD7ED"/>
-                </a:solidFill>
-              </a:rPr>
-              <a:t>Planificación → Cierre</a:t>
-            </a:r>
-          </a:p>
-        </p:txBody>
-      </p:sp>
-      <p:sp>
-        <p:nvSpPr>
-          <p:cNvPr id="100" name="TextBox 99"/>
+              <a:rPr sz="1000" b="1" i="0">
+                <a:solidFill>
+                  <a:srgbClr val="FFC000"/>
+                </a:solidFill>
+              </a:rPr>
+              <a:t>4 Hitos</a:t>
+            </a:r>
+          </a:p>
+        </p:txBody>
+      </p:sp>
+      <p:sp>
+        <p:nvSpPr>
+          <p:cNvPr id="99" name="TextBox 98"/>
           <p:cNvSpPr txBox="1"/>
           <p:nvPr/>
         </p:nvSpPr>
         <p:spPr>
           <a:xfrm>
-            <a:off x="2788920" y="6007608"/>
-            <a:ext cx="2103120" cy="228600"/>
+            <a:off x="2788920" y="6236208"/>
+            <a:ext cx="2103120" cy="182880"/>
           </a:xfrm>
           <a:prstGeom prst="rect">
             <a:avLst/>
@@ -13973,26 +13928,26 @@
           <a:p>
             <a:pPr algn="l"/>
             <a:r>
-              <a:rPr sz="1000" b="1" i="0">
-                <a:solidFill>
-                  <a:srgbClr val="FFC000"/>
-                </a:solidFill>
-              </a:rPr>
-              <a:t>4 Hitos</a:t>
-            </a:r>
-          </a:p>
-        </p:txBody>
-      </p:sp>
-      <p:sp>
-        <p:nvSpPr>
-          <p:cNvPr id="101" name="TextBox 100"/>
+              <a:rPr sz="750" b="0" i="0">
+                <a:solidFill>
+                  <a:srgbClr val="BFD7ED"/>
+                </a:solidFill>
+              </a:rPr>
+              <a:t>EDT 2.3 · 3.5 · 5.7 · 8.2</a:t>
+            </a:r>
+          </a:p>
+        </p:txBody>
+      </p:sp>
+      <p:sp>
+        <p:nvSpPr>
+          <p:cNvPr id="100" name="TextBox 99"/>
           <p:cNvSpPr txBox="1"/>
           <p:nvPr/>
         </p:nvSpPr>
         <p:spPr>
           <a:xfrm>
-            <a:off x="2788920" y="6236208"/>
-            <a:ext cx="2103120" cy="182880"/>
+            <a:off x="5120640" y="6007608"/>
+            <a:ext cx="2103120" cy="228600"/>
           </a:xfrm>
           <a:prstGeom prst="rect">
             <a:avLst/>
@@ -14007,26 +13962,26 @@
           <a:p>
             <a:pPr algn="l"/>
             <a:r>
-              <a:rPr sz="750" b="0" i="0">
-                <a:solidFill>
-                  <a:srgbClr val="BFD7ED"/>
-                </a:solidFill>
-              </a:rPr>
-              <a:t>EDT 2.3 · 3.5 · 5.7 · 8.2</a:t>
-            </a:r>
-          </a:p>
-        </p:txBody>
-      </p:sp>
-      <p:sp>
-        <p:nvSpPr>
-          <p:cNvPr id="102" name="TextBox 101"/>
+              <a:rPr sz="1000" b="1" i="0">
+                <a:solidFill>
+                  <a:srgbClr val="FFC000"/>
+                </a:solidFill>
+              </a:rPr>
+              <a:t>41 Tareas</a:t>
+            </a:r>
+          </a:p>
+        </p:txBody>
+      </p:sp>
+      <p:sp>
+        <p:nvSpPr>
+          <p:cNvPr id="101" name="TextBox 100"/>
           <p:cNvSpPr txBox="1"/>
           <p:nvPr/>
         </p:nvSpPr>
         <p:spPr>
           <a:xfrm>
-            <a:off x="5120640" y="6007608"/>
-            <a:ext cx="2103120" cy="228600"/>
+            <a:off x="5120640" y="6236208"/>
+            <a:ext cx="2103120" cy="182880"/>
           </a:xfrm>
           <a:prstGeom prst="rect">
             <a:avLst/>
@@ -14041,26 +13996,26 @@
           <a:p>
             <a:pPr algn="l"/>
             <a:r>
-              <a:rPr sz="1000" b="1" i="0">
-                <a:solidFill>
-                  <a:srgbClr val="FFC000"/>
-                </a:solidFill>
-              </a:rPr>
-              <a:t>41 Tareas</a:t>
-            </a:r>
-          </a:p>
-        </p:txBody>
-      </p:sp>
-      <p:sp>
-        <p:nvSpPr>
-          <p:cNvPr id="103" name="TextBox 102"/>
+              <a:rPr sz="750" b="0" i="0">
+                <a:solidFill>
+                  <a:srgbClr val="BFD7ED"/>
+                </a:solidFill>
+              </a:rPr>
+              <a:t>con responsable asignado</a:t>
+            </a:r>
+          </a:p>
+        </p:txBody>
+      </p:sp>
+      <p:sp>
+        <p:nvSpPr>
+          <p:cNvPr id="102" name="TextBox 101"/>
           <p:cNvSpPr txBox="1"/>
           <p:nvPr/>
         </p:nvSpPr>
         <p:spPr>
           <a:xfrm>
-            <a:off x="5120640" y="6236208"/>
-            <a:ext cx="2103120" cy="182880"/>
+            <a:off x="7452359" y="6007608"/>
+            <a:ext cx="2103120" cy="228600"/>
           </a:xfrm>
           <a:prstGeom prst="rect">
             <a:avLst/>
@@ -14075,26 +14030,26 @@
           <a:p>
             <a:pPr algn="l"/>
             <a:r>
-              <a:rPr sz="750" b="0" i="0">
-                <a:solidFill>
-                  <a:srgbClr val="BFD7ED"/>
-                </a:solidFill>
-              </a:rPr>
-              <a:t>con responsable asignado</a:t>
-            </a:r>
-          </a:p>
-        </p:txBody>
-      </p:sp>
-      <p:sp>
-        <p:nvSpPr>
-          <p:cNvPr id="104" name="TextBox 103"/>
+              <a:rPr sz="1000" b="1" i="0">
+                <a:solidFill>
+                  <a:srgbClr val="FFC000"/>
+                </a:solidFill>
+              </a:rPr>
+              <a:t>576 Horas</a:t>
+            </a:r>
+          </a:p>
+        </p:txBody>
+      </p:sp>
+      <p:sp>
+        <p:nvSpPr>
+          <p:cNvPr id="103" name="TextBox 102"/>
           <p:cNvSpPr txBox="1"/>
           <p:nvPr/>
         </p:nvSpPr>
         <p:spPr>
           <a:xfrm>
-            <a:off x="7452359" y="6007608"/>
-            <a:ext cx="2103120" cy="228600"/>
+            <a:off x="7452359" y="6236208"/>
+            <a:ext cx="2103120" cy="182880"/>
           </a:xfrm>
           <a:prstGeom prst="rect">
             <a:avLst/>
@@ -14109,26 +14064,26 @@
           <a:p>
             <a:pPr algn="l"/>
             <a:r>
-              <a:rPr sz="1000" b="1" i="0">
-                <a:solidFill>
-                  <a:srgbClr val="FFC000"/>
-                </a:solidFill>
-              </a:rPr>
-              <a:t>552 Horas</a:t>
-            </a:r>
-          </a:p>
-        </p:txBody>
-      </p:sp>
-      <p:sp>
-        <p:nvSpPr>
-          <p:cNvPr id="105" name="TextBox 104"/>
+              <a:rPr sz="750" b="0" i="0">
+                <a:solidFill>
+                  <a:srgbClr val="BFD7ED"/>
+                </a:solidFill>
+              </a:rPr>
+              <a:t>esfuerzo total planificado</a:t>
+            </a:r>
+          </a:p>
+        </p:txBody>
+      </p:sp>
+      <p:sp>
+        <p:nvSpPr>
+          <p:cNvPr id="104" name="TextBox 103"/>
           <p:cNvSpPr txBox="1"/>
           <p:nvPr/>
         </p:nvSpPr>
         <p:spPr>
           <a:xfrm>
-            <a:off x="7452359" y="6236208"/>
-            <a:ext cx="2103120" cy="182880"/>
+            <a:off x="9784080" y="6007608"/>
+            <a:ext cx="2103120" cy="228600"/>
           </a:xfrm>
           <a:prstGeom prst="rect">
             <a:avLst/>
@@ -14143,40 +14098,6 @@
           <a:p>
             <a:pPr algn="l"/>
             <a:r>
-              <a:rPr sz="750" b="0" i="0">
-                <a:solidFill>
-                  <a:srgbClr val="BFD7ED"/>
-                </a:solidFill>
-              </a:rPr>
-              <a:t>esfuerzo total planificado</a:t>
-            </a:r>
-          </a:p>
-        </p:txBody>
-      </p:sp>
-      <p:sp>
-        <p:nvSpPr>
-          <p:cNvPr id="106" name="TextBox 105"/>
-          <p:cNvSpPr txBox="1"/>
-          <p:nvPr/>
-        </p:nvSpPr>
-        <p:spPr>
-          <a:xfrm>
-            <a:off x="9784080" y="6007608"/>
-            <a:ext cx="2103120" cy="228600"/>
-          </a:xfrm>
-          <a:prstGeom prst="rect">
-            <a:avLst/>
-          </a:prstGeom>
-          <a:noFill/>
-        </p:spPr>
-        <p:txBody>
-          <a:bodyPr wrap="square">
-            <a:spAutoFit/>
-          </a:bodyPr>
-          <a:lstStyle/>
-          <a:p>
-            <a:pPr algn="l"/>
-            <a:r>
               <a:rPr sz="1000" b="1" i="0">
                 <a:solidFill>
                   <a:srgbClr val="FFC000"/>
@@ -14189,7 +14110,7 @@
       </p:sp>
       <p:sp>
         <p:nvSpPr>
-          <p:cNvPr id="107" name="TextBox 106"/>
+          <p:cNvPr id="105" name="TextBox 104"/>
           <p:cNvSpPr txBox="1"/>
           <p:nvPr/>
         </p:nvSpPr>

</xml_diff>